<commit_message>
Template polish: currency axis formatting, bottom-pinned line labels, {{mustache}} text tokens
- Value axes now format as "$"#,##0 (bar + line)
- Line category (year) labels pinned to the bottom via tickLblPos=LOW so they
  don't ride the zero crossing when profit goes negative
- Switch text placeholders from ${token} to {{token}} (the convention the
  service actually substitutes); update README accordingly
- Remove throwaway text-probe diagnostic files
</commit_message>
<xml_diff>
--- a/model/results-template.pptx
+++ b/model/results-template.pptx
@@ -245,6 +245,7 @@
         <c:delete val="0"/>
         <c:axPos val="l"/>
         <c:majorGridlines/>
+        <c:numFmt formatCode="&quot;$&quot;#,##0" sourceLinked="0"/>
         <c:majorTickMark val="out"/>
         <c:minorTickMark val="none"/>
         <c:tickLblPos val="nextTo"/>
@@ -521,7 +522,7 @@
         <c:axPos val="b"/>
         <c:majorTickMark val="out"/>
         <c:minorTickMark val="none"/>
-        <c:tickLblPos val="nextTo"/>
+        <c:tickLblPos val="low"/>
         <c:txPr>
           <a:bodyPr/>
           <a:lstStyle/>
@@ -544,6 +545,7 @@
         <c:delete val="0"/>
         <c:axPos val="l"/>
         <c:majorGridlines/>
+        <c:numFmt formatCode="&quot;$&quot;#,##0" sourceLinked="0"/>
         <c:majorTickMark val="out"/>
         <c:minorTickMark val="none"/>
         <c:tickLblPos val="nextTo"/>
@@ -3923,7 +3925,7 @@
                 </a:solidFill>
                 <a:latin typeface="Century Schoolbook"/>
               </a:rPr>
-              <a:t>${title}</a:t>
+              <a:t>{{title}}</a:t>
             </a:r>
           </a:p>
         </p:txBody>
@@ -3958,7 +3960,7 @@
                 </a:solidFill>
                 <a:latin typeface="Calibri"/>
               </a:rPr>
-              <a:t>${subtitle}</a:t>
+              <a:t>{{subtitle}}</a:t>
             </a:r>
           </a:p>
         </p:txBody>
@@ -3993,7 +3995,7 @@
                 </a:solidFill>
                 <a:latin typeface="Calibri"/>
               </a:rPr>
-              <a:t>${groupName}   •   ${episodeLabel}   •   ${participantCount} players</a:t>
+              <a:t>{{groupName}}   •   {{episodeLabel}}   •   {{participantCount}} players</a:t>
             </a:r>
           </a:p>
         </p:txBody>
@@ -4028,7 +4030,7 @@
                 </a:solidFill>
                 <a:latin typeface="Calibri"/>
               </a:rPr>
-              <a:t>Generated ${generatedOn}</a:t>
+              <a:t>Generated {{generatedOn}}</a:t>
             </a:r>
           </a:p>
         </p:txBody>
@@ -4714,7 +4716,7 @@
                 </a:solidFill>
                 <a:latin typeface="Calibri"/>
               </a:rPr>
-              <a:t>Generated ${generatedOn}</a:t>
+              <a:t>Generated {{generatedOn}}</a:t>
             </a:r>
           </a:p>
         </p:txBody>
@@ -4927,7 +4929,7 @@
                 </a:solidFill>
                 <a:latin typeface="Century Schoolbook"/>
               </a:rPr>
-              <a:t>${topPerformer}</a:t>
+              <a:t>{{topPerformer}}</a:t>
             </a:r>
           </a:p>
         </p:txBody>
@@ -5043,7 +5045,7 @@
                 </a:solidFill>
                 <a:latin typeface="Century Schoolbook"/>
               </a:rPr>
-              <a:t>${topProfit}</a:t>
+              <a:t>{{topProfit}}</a:t>
             </a:r>
           </a:p>
         </p:txBody>
@@ -5159,7 +5161,7 @@
                 </a:solidFill>
                 <a:latin typeface="Century Schoolbook"/>
               </a:rPr>
-              <a:t>${averageProfit}</a:t>
+              <a:t>{{averageProfit}}</a:t>
             </a:r>
           </a:p>
         </p:txBody>

</xml_diff>

<commit_message>
Robust text tokens + line-chart axis at bottom
- Pre-compose composite lines (summary, generated) in buildDocument() and use
  single whole-box {{token}}s in the template; the service corrupts multiple
  tokens sharing one paragraph (epicenter-1553)
- Line chart: value axis now crosses at its minimum so the category axis line
  and tick marks sit at the bottom, not on the zero line, when profit is negative
</commit_message>
<xml_diff>
--- a/model/results-template.pptx
+++ b/model/results-template.pptx
@@ -533,7 +533,7 @@
           </a:p>
         </c:txPr>
         <c:crossAx val="2140495176"/>
-        <c:crosses val="autoZero"/>
+        <c:crosses val="min"/>
         <c:auto val="1"/>
         <c:lblAlgn val="ctr"/>
         <c:lblOffset val="100"/>
@@ -3995,7 +3995,7 @@
                 </a:solidFill>
                 <a:latin typeface="Calibri"/>
               </a:rPr>
-              <a:t>{{groupName}}   •   {{episodeLabel}}   •   {{participantCount}} players</a:t>
+              <a:t>{{summary}}</a:t>
             </a:r>
           </a:p>
         </p:txBody>
@@ -4030,7 +4030,7 @@
                 </a:solidFill>
                 <a:latin typeface="Calibri"/>
               </a:rPr>
-              <a:t>Generated {{generatedOn}}</a:t>
+              <a:t>{{generated}}</a:t>
             </a:r>
           </a:p>
         </p:txBody>
@@ -4716,7 +4716,7 @@
                 </a:solidFill>
                 <a:latin typeface="Calibri"/>
               </a:rPr>
-              <a:t>Generated {{generatedOn}}</a:t>
+              <a:t>{{generated}}</a:t>
             </a:r>
           </a:p>
         </p:txBody>

</xml_diff>